<commit_message>
docs: add submission supporting PDFs
</commit_message>
<xml_diff>
--- a/submission/VAXMOMENT_PITCH_DECK.pptx
+++ b/submission/VAXMOMENT_PITCH_DECK.pptx
@@ -4238,7 +4238,7 @@
                   <a:srgbClr val="167C75"/>
                 </a:solidFill>
               </a:rPr>
-              <a:t>Market insight</a:t>
+              <a:t>Market hypothesis</a:t>
             </a:r>
             <a:endParaRPr lang="en-US" sz="1200" dirty="0"/>
           </a:p>
@@ -4279,7 +4279,7 @@
                 <a:ea typeface="Aptos Display" pitchFamily="34" charset="-122"/>
                 <a:cs typeface="Aptos Display" pitchFamily="34" charset="-120"/>
               </a:rPr>
-              <a:t>People stall for different reasons—practical access, confidence, information, private clinical questions or simply no concrete plan. The product must remove the specific friction, not send a smarter-looking reminder.</a:t>
+              <a:t>People may stall for different reasons—practical access, confidence, information, private clinical questions or simply no concrete plan. The product must test and remove the specific friction, not send a smarter-looking reminder.</a:t>
             </a:r>
             <a:endParaRPr lang="en-US" sz="2200" dirty="0"/>
           </a:p>
@@ -10314,7 +10314,7 @@
                 <a:ea typeface="Aptos" pitchFamily="34" charset="-122"/>
                 <a:cs typeface="Aptos" pitchFamily="34" charset="-120"/>
               </a:rPr>
-              <a:t>Typed ports, deterministic adapters, policy/state/privacy tests, Adaptive Card payloads, tool contracts and a failure-safe public prototype.</a:t>
+              <a:t>Typed ports, deterministic adapters, policy/state/privacy tests, Adaptive Card payloads, tool contracts and tested fallback and denial paths.</a:t>
             </a:r>
             <a:endParaRPr lang="en-US" sz="1050" dirty="0"/>
           </a:p>

</xml_diff>